<commit_message>
Link people, timeline and knowledge-transfer pages in the simplified deck
Page 6: Huawei row reworded as what Huawei provides; add a line that
knowledge transfer runs through all five phases. Page 7: retitle as
what RNP puts in; add a column mapping each role to deliverable and
phase. Page 8: retitle as what RNP takes away; capability outcomes
listed per role to mirror page 7; add a line positioning iFLYTEK's
part inside the Huawei capacity programme.

Co-Authored-By: Claude Fable 5.1 <noreply@anthropic.com>
Claude-Session: https://claude.ai/code/session_013YNLX1YpdFGo5x78EUfMBb
</commit_message>
<xml_diff>
--- a/RNP-讯飞交流-中文简版.pptx
+++ b/RNP-讯飞交流-中文简版.pptx
@@ -13771,8 +13771,8 @@
         </p:nvSpPr>
         <p:spPr>
           <a:xfrm>
-            <a:off x="457200" y="1051560"/>
-            <a:ext cx="2050084" cy="2651760"/>
+            <a:off x="457200" y="1005840"/>
+            <a:ext cx="2050084" cy="2377440"/>
           </a:xfrm>
           <a:prstGeom prst="roundRect">
             <a:avLst>
@@ -13817,8 +13817,8 @@
         </p:nvSpPr>
         <p:spPr>
           <a:xfrm>
-            <a:off x="1253642" y="1307592"/>
-            <a:ext cx="457200" cy="457200"/>
+            <a:off x="1271930" y="1207008"/>
+            <a:ext cx="420624" cy="420624"/>
           </a:xfrm>
           <a:prstGeom prst="ellipse">
             <a:avLst/>
@@ -13860,7 +13860,7 @@
               </a:spcAft>
             </a:pPr>
             <a:r>
-              <a:rPr sz="1400" b="1">
+              <a:rPr sz="1300" b="1">
                 <a:solidFill>
                   <a:srgbClr val="FFFFFF"/>
                 </a:solidFill>
@@ -13880,8 +13880,8 @@
         </p:nvSpPr>
         <p:spPr>
           <a:xfrm>
-            <a:off x="548640" y="1874519"/>
-            <a:ext cx="1867204" cy="411480"/>
+            <a:off x="548640" y="1719072"/>
+            <a:ext cx="1867204" cy="384048"/>
           </a:xfrm>
           <a:prstGeom prst="rect">
             <a:avLst/>
@@ -13923,8 +13923,8 @@
         </p:nvSpPr>
         <p:spPr>
           <a:xfrm>
-            <a:off x="640080" y="2377439"/>
-            <a:ext cx="1684324" cy="777240"/>
+            <a:off x="640080" y="2176272"/>
+            <a:ext cx="1684324" cy="731520"/>
           </a:xfrm>
           <a:prstGeom prst="rect">
             <a:avLst/>
@@ -13986,8 +13986,8 @@
         </p:nvSpPr>
         <p:spPr>
           <a:xfrm>
-            <a:off x="640080" y="3200400"/>
-            <a:ext cx="1684324" cy="365760"/>
+            <a:off x="640080" y="2944368"/>
+            <a:ext cx="1684324" cy="347472"/>
           </a:xfrm>
           <a:prstGeom prst="rect">
             <a:avLst/>
@@ -14029,7 +14029,7 @@
         </p:nvSpPr>
         <p:spPr>
           <a:xfrm>
-            <a:off x="2534716" y="1965960"/>
+            <a:off x="2534716" y="1828800"/>
             <a:ext cx="201168" cy="201168"/>
           </a:xfrm>
           <a:prstGeom prst="rightArrow">
@@ -14073,8 +14073,8 @@
         </p:nvSpPr>
         <p:spPr>
           <a:xfrm>
-            <a:off x="2763316" y="1051560"/>
-            <a:ext cx="2050084" cy="2651760"/>
+            <a:off x="2763316" y="1005840"/>
+            <a:ext cx="2050084" cy="2377440"/>
           </a:xfrm>
           <a:prstGeom prst="roundRect">
             <a:avLst>
@@ -14119,8 +14119,8 @@
         </p:nvSpPr>
         <p:spPr>
           <a:xfrm>
-            <a:off x="3559759" y="1307592"/>
-            <a:ext cx="457200" cy="457200"/>
+            <a:off x="3578047" y="1207008"/>
+            <a:ext cx="420624" cy="420624"/>
           </a:xfrm>
           <a:prstGeom prst="ellipse">
             <a:avLst/>
@@ -14162,7 +14162,7 @@
               </a:spcAft>
             </a:pPr>
             <a:r>
-              <a:rPr sz="1400" b="1">
+              <a:rPr sz="1300" b="1">
                 <a:solidFill>
                   <a:srgbClr val="FFFFFF"/>
                 </a:solidFill>
@@ -14182,8 +14182,8 @@
         </p:nvSpPr>
         <p:spPr>
           <a:xfrm>
-            <a:off x="2854756" y="1874519"/>
-            <a:ext cx="1867204" cy="411480"/>
+            <a:off x="2854756" y="1719072"/>
+            <a:ext cx="1867204" cy="384048"/>
           </a:xfrm>
           <a:prstGeom prst="rect">
             <a:avLst/>
@@ -14225,8 +14225,8 @@
         </p:nvSpPr>
         <p:spPr>
           <a:xfrm>
-            <a:off x="2946196" y="2377439"/>
-            <a:ext cx="1684324" cy="777240"/>
+            <a:off x="2946196" y="2176272"/>
+            <a:ext cx="1684324" cy="731520"/>
           </a:xfrm>
           <a:prstGeom prst="rect">
             <a:avLst/>
@@ -14288,8 +14288,8 @@
         </p:nvSpPr>
         <p:spPr>
           <a:xfrm>
-            <a:off x="2946196" y="3200400"/>
-            <a:ext cx="1684324" cy="365760"/>
+            <a:off x="2946196" y="2944368"/>
+            <a:ext cx="1684324" cy="347472"/>
           </a:xfrm>
           <a:prstGeom prst="rect">
             <a:avLst/>
@@ -14331,7 +14331,7 @@
         </p:nvSpPr>
         <p:spPr>
           <a:xfrm>
-            <a:off x="4840833" y="1965960"/>
+            <a:off x="4840833" y="1828800"/>
             <a:ext cx="201168" cy="201168"/>
           </a:xfrm>
           <a:prstGeom prst="rightArrow">
@@ -14375,8 +14375,8 @@
         </p:nvSpPr>
         <p:spPr>
           <a:xfrm>
-            <a:off x="5069433" y="1051560"/>
-            <a:ext cx="2050084" cy="2651760"/>
+            <a:off x="5069433" y="1005840"/>
+            <a:ext cx="2050084" cy="2377440"/>
           </a:xfrm>
           <a:prstGeom prst="roundRect">
             <a:avLst>
@@ -14421,8 +14421,8 @@
         </p:nvSpPr>
         <p:spPr>
           <a:xfrm>
-            <a:off x="5865876" y="1307592"/>
-            <a:ext cx="457200" cy="457200"/>
+            <a:off x="5884164" y="1207008"/>
+            <a:ext cx="420624" cy="420624"/>
           </a:xfrm>
           <a:prstGeom prst="ellipse">
             <a:avLst/>
@@ -14464,7 +14464,7 @@
               </a:spcAft>
             </a:pPr>
             <a:r>
-              <a:rPr sz="1400" b="1">
+              <a:rPr sz="1300" b="1">
                 <a:solidFill>
                   <a:srgbClr val="FFFFFF"/>
                 </a:solidFill>
@@ -14484,8 +14484,8 @@
         </p:nvSpPr>
         <p:spPr>
           <a:xfrm>
-            <a:off x="5160873" y="1874519"/>
-            <a:ext cx="1867204" cy="411480"/>
+            <a:off x="5160873" y="1719072"/>
+            <a:ext cx="1867204" cy="384048"/>
           </a:xfrm>
           <a:prstGeom prst="rect">
             <a:avLst/>
@@ -14527,8 +14527,8 @@
         </p:nvSpPr>
         <p:spPr>
           <a:xfrm>
-            <a:off x="5252313" y="2377439"/>
-            <a:ext cx="1684324" cy="777240"/>
+            <a:off x="5252313" y="2176272"/>
+            <a:ext cx="1684324" cy="731520"/>
           </a:xfrm>
           <a:prstGeom prst="rect">
             <a:avLst/>
@@ -14590,8 +14590,8 @@
         </p:nvSpPr>
         <p:spPr>
           <a:xfrm>
-            <a:off x="5252313" y="3200400"/>
-            <a:ext cx="1684324" cy="365760"/>
+            <a:off x="5252313" y="2944368"/>
+            <a:ext cx="1684324" cy="347472"/>
           </a:xfrm>
           <a:prstGeom prst="rect">
             <a:avLst/>
@@ -14633,7 +14633,7 @@
         </p:nvSpPr>
         <p:spPr>
           <a:xfrm>
-            <a:off x="7146950" y="1965960"/>
+            <a:off x="7146950" y="1828800"/>
             <a:ext cx="201168" cy="201168"/>
           </a:xfrm>
           <a:prstGeom prst="rightArrow">
@@ -14677,8 +14677,8 @@
         </p:nvSpPr>
         <p:spPr>
           <a:xfrm>
-            <a:off x="7375550" y="1051560"/>
-            <a:ext cx="2050084" cy="2651760"/>
+            <a:off x="7375550" y="1005840"/>
+            <a:ext cx="2050084" cy="2377440"/>
           </a:xfrm>
           <a:prstGeom prst="roundRect">
             <a:avLst>
@@ -14723,8 +14723,8 @@
         </p:nvSpPr>
         <p:spPr>
           <a:xfrm>
-            <a:off x="8171992" y="1307592"/>
-            <a:ext cx="457200" cy="457200"/>
+            <a:off x="8190280" y="1207008"/>
+            <a:ext cx="420624" cy="420624"/>
           </a:xfrm>
           <a:prstGeom prst="ellipse">
             <a:avLst/>
@@ -14766,7 +14766,7 @@
               </a:spcAft>
             </a:pPr>
             <a:r>
-              <a:rPr sz="1400" b="1">
+              <a:rPr sz="1300" b="1">
                 <a:solidFill>
                   <a:srgbClr val="FFFFFF"/>
                 </a:solidFill>
@@ -14786,8 +14786,8 @@
         </p:nvSpPr>
         <p:spPr>
           <a:xfrm>
-            <a:off x="7466990" y="1874519"/>
-            <a:ext cx="1867204" cy="411480"/>
+            <a:off x="7466990" y="1719072"/>
+            <a:ext cx="1867204" cy="384048"/>
           </a:xfrm>
           <a:prstGeom prst="rect">
             <a:avLst/>
@@ -14829,8 +14829,8 @@
         </p:nvSpPr>
         <p:spPr>
           <a:xfrm>
-            <a:off x="7558430" y="2377439"/>
-            <a:ext cx="1684324" cy="777240"/>
+            <a:off x="7558430" y="2176272"/>
+            <a:ext cx="1684324" cy="731520"/>
           </a:xfrm>
           <a:prstGeom prst="rect">
             <a:avLst/>
@@ -14892,8 +14892,8 @@
         </p:nvSpPr>
         <p:spPr>
           <a:xfrm>
-            <a:off x="7558430" y="3200400"/>
-            <a:ext cx="1684324" cy="365760"/>
+            <a:off x="7558430" y="2944368"/>
+            <a:ext cx="1684324" cy="347472"/>
           </a:xfrm>
           <a:prstGeom prst="rect">
             <a:avLst/>
@@ -14935,7 +14935,7 @@
         </p:nvSpPr>
         <p:spPr>
           <a:xfrm>
-            <a:off x="9453067" y="1965960"/>
+            <a:off x="9453067" y="1828800"/>
             <a:ext cx="201168" cy="201168"/>
           </a:xfrm>
           <a:prstGeom prst="rightArrow">
@@ -14979,8 +14979,8 @@
         </p:nvSpPr>
         <p:spPr>
           <a:xfrm>
-            <a:off x="9681667" y="1051560"/>
-            <a:ext cx="2050084" cy="2651760"/>
+            <a:off x="9681667" y="1005840"/>
+            <a:ext cx="2050084" cy="2377440"/>
           </a:xfrm>
           <a:prstGeom prst="roundRect">
             <a:avLst>
@@ -15025,8 +15025,8 @@
         </p:nvSpPr>
         <p:spPr>
           <a:xfrm>
-            <a:off x="10478109" y="1307592"/>
-            <a:ext cx="457200" cy="457200"/>
+            <a:off x="10496397" y="1207008"/>
+            <a:ext cx="420624" cy="420624"/>
           </a:xfrm>
           <a:prstGeom prst="ellipse">
             <a:avLst/>
@@ -15068,7 +15068,7 @@
               </a:spcAft>
             </a:pPr>
             <a:r>
-              <a:rPr sz="1400" b="1">
+              <a:rPr sz="1300" b="1">
                 <a:solidFill>
                   <a:srgbClr val="FFFFFF"/>
                 </a:solidFill>
@@ -15088,8 +15088,8 @@
         </p:nvSpPr>
         <p:spPr>
           <a:xfrm>
-            <a:off x="9773107" y="1874519"/>
-            <a:ext cx="1867204" cy="411480"/>
+            <a:off x="9773107" y="1719072"/>
+            <a:ext cx="1867204" cy="384048"/>
           </a:xfrm>
           <a:prstGeom prst="rect">
             <a:avLst/>
@@ -15131,8 +15131,8 @@
         </p:nvSpPr>
         <p:spPr>
           <a:xfrm>
-            <a:off x="9864547" y="2377439"/>
-            <a:ext cx="1684324" cy="777240"/>
+            <a:off x="9864547" y="2176272"/>
+            <a:ext cx="1684324" cy="731520"/>
           </a:xfrm>
           <a:prstGeom prst="rect">
             <a:avLst/>
@@ -15194,8 +15194,8 @@
         </p:nvSpPr>
         <p:spPr>
           <a:xfrm>
-            <a:off x="9864547" y="3200400"/>
-            <a:ext cx="1684324" cy="365760"/>
+            <a:off x="9864547" y="2944368"/>
+            <a:ext cx="1684324" cy="347472"/>
           </a:xfrm>
           <a:prstGeom prst="rect">
             <a:avLst/>
@@ -15237,8 +15237,8 @@
         </p:nvSpPr>
         <p:spPr>
           <a:xfrm>
-            <a:off x="457200" y="3977639"/>
-            <a:ext cx="11274552" cy="566928"/>
+            <a:off x="457200" y="3611880"/>
+            <a:ext cx="11274552" cy="530352"/>
           </a:xfrm>
           <a:prstGeom prst="roundRect">
             <a:avLst>
@@ -15285,8 +15285,8 @@
         </p:nvSpPr>
         <p:spPr>
           <a:xfrm>
-            <a:off x="685800" y="4105655"/>
-            <a:ext cx="1645920" cy="310896"/>
+            <a:off x="685800" y="3721608"/>
+            <a:ext cx="1463040" cy="310896"/>
           </a:xfrm>
           <a:prstGeom prst="rect">
             <a:avLst/>
@@ -15315,7 +15315,7 @@
                 <a:latin typeface="微软雅黑"/>
                 <a:ea typeface="微软雅黑"/>
               </a:rPr>
-              <a:t>华为平台依赖</a:t>
+              <a:t>华为提供</a:t>
             </a:r>
           </a:p>
         </p:txBody>
@@ -15328,8 +15328,8 @@
         </p:nvSpPr>
         <p:spPr>
           <a:xfrm>
-            <a:off x="2331720" y="4087368"/>
-            <a:ext cx="9171432" cy="384048"/>
+            <a:off x="2148840" y="3721608"/>
+            <a:ext cx="9354312" cy="347471"/>
           </a:xfrm>
           <a:prstGeom prst="rect">
             <a:avLst/>
@@ -15358,7 +15358,7 @@
                 <a:latin typeface="微软雅黑"/>
                 <a:ea typeface="微软雅黑"/>
               </a:rPr>
-              <a:t>训练与推理算力　·　部署环境与网络　·　数据中心运维衔接　　（单列，不计入讯飞责任）</a:t>
+              <a:t>训练与推理算力　·　部署环境与网络　·　数据中心运维衔接　　（三方责任中的华为部分）</a:t>
             </a:r>
           </a:p>
         </p:txBody>
@@ -15371,8 +15371,140 @@
         </p:nvSpPr>
         <p:spPr>
           <a:xfrm>
-            <a:off x="457200" y="4754880"/>
-            <a:ext cx="11274552" cy="566928"/>
+            <a:off x="457200" y="4297680"/>
+            <a:ext cx="11274552" cy="530352"/>
+          </a:xfrm>
+          <a:prstGeom prst="roundRect">
+            <a:avLst>
+              <a:gd name="adj" fmla="val 4000"/>
+            </a:avLst>
+          </a:prstGeom>
+          <a:solidFill>
+            <a:srgbClr val="FBE5E9"/>
+          </a:solidFill>
+          <a:ln>
+            <a:noFill/>
+          </a:ln>
+          <a:effectLst/>
+        </p:spPr>
+        <p:style>
+          <a:lnRef idx="1">
+            <a:schemeClr val="accent1"/>
+          </a:lnRef>
+          <a:fillRef idx="3">
+            <a:schemeClr val="accent1"/>
+          </a:fillRef>
+          <a:effectRef idx="2">
+            <a:schemeClr val="accent1"/>
+          </a:effectRef>
+          <a:fontRef idx="minor">
+            <a:schemeClr val="lt1"/>
+          </a:fontRef>
+        </p:style>
+        <p:txBody>
+          <a:bodyPr rtlCol="0" anchor="ctr"/>
+          <a:lstStyle/>
+          <a:p>
+            <a:pPr algn="ctr"/>
+          </a:p>
+        </p:txBody>
+      </p:sp>
+      <p:sp>
+        <p:nvSpPr>
+          <p:cNvPr id="36" name="TextBox 35"/>
+          <p:cNvSpPr txBox="1"/>
+          <p:nvPr/>
+        </p:nvSpPr>
+        <p:spPr>
+          <a:xfrm>
+            <a:off x="685800" y="4407408"/>
+            <a:ext cx="1463040" cy="310896"/>
+          </a:xfrm>
+          <a:prstGeom prst="rect">
+            <a:avLst/>
+          </a:prstGeom>
+          <a:noFill/>
+        </p:spPr>
+        <p:txBody>
+          <a:bodyPr wrap="square" lIns="0" tIns="0" rIns="0" bIns="0" anchor="ctr">
+            <a:noAutofit/>
+          </a:bodyPr>
+          <a:lstStyle/>
+          <a:p>
+            <a:pPr algn="l">
+              <a:lnSpc>
+                <a:spcPct val="115000"/>
+              </a:lnSpc>
+              <a:spcAft>
+                <a:spcPts val="0"/>
+              </a:spcAft>
+            </a:pPr>
+            <a:r>
+              <a:rPr sz="1250" b="1">
+                <a:solidFill>
+                  <a:srgbClr val="C00000"/>
+                </a:solidFill>
+                <a:latin typeface="微软雅黑"/>
+                <a:ea typeface="微软雅黑"/>
+              </a:rPr>
+              <a:t>知识转移</a:t>
+            </a:r>
+          </a:p>
+        </p:txBody>
+      </p:sp>
+      <p:sp>
+        <p:nvSpPr>
+          <p:cNvPr id="37" name="TextBox 36"/>
+          <p:cNvSpPr txBox="1"/>
+          <p:nvPr/>
+        </p:nvSpPr>
+        <p:spPr>
+          <a:xfrm>
+            <a:off x="2148840" y="4407408"/>
+            <a:ext cx="9354312" cy="347471"/>
+          </a:xfrm>
+          <a:prstGeom prst="rect">
+            <a:avLst/>
+          </a:prstGeom>
+          <a:noFill/>
+        </p:spPr>
+        <p:txBody>
+          <a:bodyPr wrap="square" lIns="0" tIns="0" rIns="0" bIns="0" anchor="ctr">
+            <a:noAutofit/>
+          </a:bodyPr>
+          <a:lstStyle/>
+          <a:p>
+            <a:pPr algn="l">
+              <a:lnSpc>
+                <a:spcPct val="115000"/>
+              </a:lnSpc>
+              <a:spcAft>
+                <a:spcPts val="400"/>
+              </a:spcAft>
+            </a:pPr>
+            <a:r>
+              <a:rPr sz="1200" b="0">
+                <a:solidFill>
+                  <a:srgbClr val="333333"/>
+                </a:solidFill>
+                <a:latin typeface="微软雅黑"/>
+                <a:ea typeface="微软雅黑"/>
+              </a:rPr>
+              <a:t>贯穿五个阶段：巴方人员在每个阶段与讯飞一起做，不是等交付完成后才开始学</a:t>
+            </a:r>
+          </a:p>
+        </p:txBody>
+      </p:sp>
+      <p:sp>
+        <p:nvSpPr>
+          <p:cNvPr id="38" name="Rounded Rectangle 37"/>
+          <p:cNvSpPr/>
+          <p:nvPr/>
+        </p:nvSpPr>
+        <p:spPr>
+          <a:xfrm>
+            <a:off x="457200" y="4983480"/>
+            <a:ext cx="11274552" cy="530352"/>
           </a:xfrm>
           <a:prstGeom prst="roundRect">
             <a:avLst>
@@ -15413,14 +15545,14 @@
       </p:sp>
       <p:sp>
         <p:nvSpPr>
-          <p:cNvPr id="36" name="TextBox 35"/>
+          <p:cNvPr id="39" name="TextBox 38"/>
           <p:cNvSpPr txBox="1"/>
           <p:nvPr/>
         </p:nvSpPr>
         <p:spPr>
           <a:xfrm>
-            <a:off x="685800" y="4882896"/>
-            <a:ext cx="1645920" cy="310896"/>
+            <a:off x="685800" y="5093208"/>
+            <a:ext cx="1463040" cy="310896"/>
           </a:xfrm>
           <a:prstGeom prst="rect">
             <a:avLst/>
@@ -15456,14 +15588,14 @@
       </p:sp>
       <p:sp>
         <p:nvSpPr>
-          <p:cNvPr id="37" name="TextBox 36"/>
+          <p:cNvPr id="40" name="TextBox 39"/>
           <p:cNvSpPr txBox="1"/>
           <p:nvPr/>
         </p:nvSpPr>
         <p:spPr>
           <a:xfrm>
-            <a:off x="2331720" y="4864608"/>
-            <a:ext cx="9171432" cy="384048"/>
+            <a:off x="2148840" y="5093208"/>
+            <a:ext cx="9354312" cy="347471"/>
           </a:xfrm>
           <a:prstGeom prst="rect">
             <a:avLst/>
@@ -15499,13 +15631,13 @@
       </p:sp>
       <p:sp>
         <p:nvSpPr>
-          <p:cNvPr id="38" name="TextBox 37"/>
+          <p:cNvPr id="41" name="TextBox 40"/>
           <p:cNvSpPr txBox="1"/>
           <p:nvPr/>
         </p:nvSpPr>
         <p:spPr>
           <a:xfrm>
-            <a:off x="457200" y="5577840"/>
+            <a:off x="457200" y="5669280"/>
             <a:ext cx="11274552" cy="365760"/>
           </a:xfrm>
           <a:prstGeom prst="rect">
@@ -15591,7 +15723,7 @@
                 <a:latin typeface="微软雅黑"/>
                 <a:ea typeface="微软雅黑"/>
               </a:rPr>
-              <a:t>RNP 需要投入的人员与资源</a:t>
+              <a:t>RNP 需要投入什么：人员与资源</a:t>
             </a:r>
           </a:p>
         </p:txBody>
@@ -15615,10 +15747,11 @@
                 <a:tableStyleId>{2D5ABB26-0587-4C30-8999-92F81FD0307C}</a:tableStyleId>
               </a:tblPr>
               <a:tblGrid>
-                <a:gridCol w="2011680"/>
-                <a:gridCol w="4023360"/>
+                <a:gridCol w="1645920"/>
                 <a:gridCol w="3108960"/>
-                <a:gridCol w="2130552"/>
+                <a:gridCol w="2377440"/>
+                <a:gridCol w="2743200"/>
+                <a:gridCol w="1399032"/>
               </a:tblGrid>
               <a:tr h="411480">
                 <a:tc>
@@ -15815,6 +15948,63 @@
                           <a:latin typeface="微软雅黑"/>
                           <a:ea typeface="微软雅黑"/>
                         </a:rPr>
+                        <a:t>参与哪项 · 阶段</a:t>
+                      </a:r>
+                    </a:p>
+                  </a:txBody>
+                  <a:tcPr anchor="ctr">
+                    <a:lnL w="6350" cap="flat" cmpd="sng" algn="ctr">
+                      <a:solidFill>
+                        <a:srgbClr val="C00000"/>
+                      </a:solidFill>
+                      <a:prstDash val="solid"/>
+                    </a:lnL>
+                    <a:lnR w="6350" cap="flat" cmpd="sng" algn="ctr">
+                      <a:solidFill>
+                        <a:srgbClr val="C00000"/>
+                      </a:solidFill>
+                      <a:prstDash val="solid"/>
+                    </a:lnR>
+                    <a:lnT w="6350" cap="flat" cmpd="sng" algn="ctr">
+                      <a:solidFill>
+                        <a:srgbClr val="C00000"/>
+                      </a:solidFill>
+                      <a:prstDash val="solid"/>
+                    </a:lnT>
+                    <a:lnB w="6350" cap="flat" cmpd="sng" algn="ctr">
+                      <a:solidFill>
+                        <a:srgbClr val="C00000"/>
+                      </a:solidFill>
+                      <a:prstDash val="solid"/>
+                    </a:lnB>
+                    <a:solidFill>
+                      <a:srgbClr val="C00000"/>
+                    </a:solidFill>
+                  </a:tcPr>
+                </a:tc>
+                <a:tc>
+                  <a:txBody>
+                    <a:bodyPr wrap="square" lIns="73152" tIns="18288" rIns="73152" bIns="18288" anchor="ctr">
+                      <a:noAutofit/>
+                    </a:bodyPr>
+                    <a:lstStyle/>
+                    <a:p>
+                      <a:pPr algn="l">
+                        <a:lnSpc>
+                          <a:spcPct val="115000"/>
+                        </a:lnSpc>
+                        <a:spcAft>
+                          <a:spcPts val="0"/>
+                        </a:spcAft>
+                      </a:pPr>
+                      <a:r>
+                        <a:rPr sz="1150" b="1">
+                          <a:solidFill>
+                            <a:srgbClr val="FFFFFF"/>
+                          </a:solidFill>
+                          <a:latin typeface="微软雅黑"/>
+                          <a:ea typeface="微软雅黑"/>
+                        </a:rPr>
                         <a:t>人数</a:t>
                       </a:r>
                     </a:p>
@@ -15867,7 +16057,7 @@
                         </a:spcAft>
                       </a:pPr>
                       <a:r>
-                        <a:rPr sz="1200" b="1">
+                        <a:rPr sz="1150" b="1">
                           <a:solidFill>
                             <a:srgbClr val="1D1D1A"/>
                           </a:solidFill>
@@ -15924,7 +16114,7 @@
                         </a:spcAft>
                       </a:pPr>
                       <a:r>
-                        <a:rPr sz="1200" b="0">
+                        <a:rPr sz="1150" b="0">
                           <a:solidFill>
                             <a:srgbClr val="333333"/>
                           </a:solidFill>
@@ -15981,7 +16171,7 @@
                         </a:spcAft>
                       </a:pPr>
                       <a:r>
-                        <a:rPr sz="1200" b="0">
+                        <a:rPr sz="1150" b="0">
                           <a:solidFill>
                             <a:srgbClr val="333333"/>
                           </a:solidFill>
@@ -16038,7 +16228,64 @@
                         </a:spcAft>
                       </a:pPr>
                       <a:r>
-                        <a:rPr sz="1200" b="0">
+                        <a:rPr sz="1150" b="0">
+                          <a:solidFill>
+                            <a:srgbClr val="333333"/>
+                          </a:solidFill>
+                          <a:latin typeface="微软雅黑"/>
+                          <a:ea typeface="微软雅黑"/>
+                        </a:rPr>
+                        <a:t>全部 · 阶段 1–5</a:t>
+                      </a:r>
+                    </a:p>
+                  </a:txBody>
+                  <a:tcPr anchor="ctr">
+                    <a:lnL w="6350" cap="flat" cmpd="sng" algn="ctr">
+                      <a:solidFill>
+                        <a:srgbClr val="D9D9D9"/>
+                      </a:solidFill>
+                      <a:prstDash val="solid"/>
+                    </a:lnL>
+                    <a:lnR w="6350" cap="flat" cmpd="sng" algn="ctr">
+                      <a:solidFill>
+                        <a:srgbClr val="D9D9D9"/>
+                      </a:solidFill>
+                      <a:prstDash val="solid"/>
+                    </a:lnR>
+                    <a:lnT w="6350" cap="flat" cmpd="sng" algn="ctr">
+                      <a:solidFill>
+                        <a:srgbClr val="D9D9D9"/>
+                      </a:solidFill>
+                      <a:prstDash val="solid"/>
+                    </a:lnT>
+                    <a:lnB w="6350" cap="flat" cmpd="sng" algn="ctr">
+                      <a:solidFill>
+                        <a:srgbClr val="D9D9D9"/>
+                      </a:solidFill>
+                      <a:prstDash val="solid"/>
+                    </a:lnB>
+                    <a:solidFill>
+                      <a:srgbClr val="FFFFFF"/>
+                    </a:solidFill>
+                  </a:tcPr>
+                </a:tc>
+                <a:tc>
+                  <a:txBody>
+                    <a:bodyPr wrap="square" lIns="73152" tIns="36576" rIns="73152" bIns="36576" anchor="ctr">
+                      <a:noAutofit/>
+                    </a:bodyPr>
+                    <a:lstStyle/>
+                    <a:p>
+                      <a:pPr algn="l">
+                        <a:lnSpc>
+                          <a:spcPct val="110000"/>
+                        </a:lnSpc>
+                        <a:spcAft>
+                          <a:spcPts val="100"/>
+                        </a:spcAft>
+                      </a:pPr>
+                      <a:r>
+                        <a:rPr sz="1150" b="0">
                           <a:solidFill>
                             <a:srgbClr val="0070C0"/>
                           </a:solidFill>
@@ -16097,7 +16344,7 @@
                         </a:spcAft>
                       </a:pPr>
                       <a:r>
-                        <a:rPr sz="1200" b="1">
+                        <a:rPr sz="1150" b="1">
                           <a:solidFill>
                             <a:srgbClr val="1D1D1A"/>
                           </a:solidFill>
@@ -16154,7 +16401,7 @@
                         </a:spcAft>
                       </a:pPr>
                       <a:r>
-                        <a:rPr sz="1200" b="0">
+                        <a:rPr sz="1150" b="0">
                           <a:solidFill>
                             <a:srgbClr val="333333"/>
                           </a:solidFill>
@@ -16211,7 +16458,7 @@
                         </a:spcAft>
                       </a:pPr>
                       <a:r>
-                        <a:rPr sz="1200" b="0">
+                        <a:rPr sz="1150" b="0">
                           <a:solidFill>
                             <a:srgbClr val="333333"/>
                           </a:solidFill>
@@ -16268,7 +16515,74 @@
                         </a:spcAft>
                       </a:pPr>
                       <a:r>
-                        <a:rPr sz="1200" b="0">
+                        <a:rPr sz="1150" b="0">
+                          <a:solidFill>
+                            <a:srgbClr val="333333"/>
+                          </a:solidFill>
+                          <a:latin typeface="微软雅黑"/>
+                          <a:ea typeface="微软雅黑"/>
+                        </a:rPr>
+                        <a:t>领域模型 · </a:t>
+                      </a:r>
+                      <a:r>
+                        <a:rPr sz="1150" b="0">
+                          <a:solidFill>
+                            <a:srgbClr val="0070C0"/>
+                          </a:solidFill>
+                          <a:latin typeface="微软雅黑"/>
+                          <a:ea typeface="微软雅黑"/>
+                        </a:rPr>
+                        <a:t>示例：阶段 3–4</a:t>
+                      </a:r>
+                    </a:p>
+                  </a:txBody>
+                  <a:tcPr anchor="ctr">
+                    <a:lnL w="6350" cap="flat" cmpd="sng" algn="ctr">
+                      <a:solidFill>
+                        <a:srgbClr val="D9D9D9"/>
+                      </a:solidFill>
+                      <a:prstDash val="solid"/>
+                    </a:lnL>
+                    <a:lnR w="6350" cap="flat" cmpd="sng" algn="ctr">
+                      <a:solidFill>
+                        <a:srgbClr val="D9D9D9"/>
+                      </a:solidFill>
+                      <a:prstDash val="solid"/>
+                    </a:lnR>
+                    <a:lnT w="6350" cap="flat" cmpd="sng" algn="ctr">
+                      <a:solidFill>
+                        <a:srgbClr val="D9D9D9"/>
+                      </a:solidFill>
+                      <a:prstDash val="solid"/>
+                    </a:lnT>
+                    <a:lnB w="6350" cap="flat" cmpd="sng" algn="ctr">
+                      <a:solidFill>
+                        <a:srgbClr val="D9D9D9"/>
+                      </a:solidFill>
+                      <a:prstDash val="solid"/>
+                    </a:lnB>
+                    <a:solidFill>
+                      <a:srgbClr val="FFFFFF"/>
+                    </a:solidFill>
+                  </a:tcPr>
+                </a:tc>
+                <a:tc>
+                  <a:txBody>
+                    <a:bodyPr wrap="square" lIns="73152" tIns="36576" rIns="73152" bIns="36576" anchor="ctr">
+                      <a:noAutofit/>
+                    </a:bodyPr>
+                    <a:lstStyle/>
+                    <a:p>
+                      <a:pPr algn="l">
+                        <a:lnSpc>
+                          <a:spcPct val="110000"/>
+                        </a:lnSpc>
+                        <a:spcAft>
+                          <a:spcPts val="100"/>
+                        </a:spcAft>
+                      </a:pPr>
+                      <a:r>
+                        <a:rPr sz="1150" b="0">
                           <a:solidFill>
                             <a:srgbClr val="0070C0"/>
                           </a:solidFill>
@@ -16327,7 +16641,7 @@
                         </a:spcAft>
                       </a:pPr>
                       <a:r>
-                        <a:rPr sz="1200" b="1">
+                        <a:rPr sz="1150" b="1">
                           <a:solidFill>
                             <a:srgbClr val="1D1D1A"/>
                           </a:solidFill>
@@ -16384,7 +16698,7 @@
                         </a:spcAft>
                       </a:pPr>
                       <a:r>
-                        <a:rPr sz="1200" b="0">
+                        <a:rPr sz="1150" b="0">
                           <a:solidFill>
                             <a:srgbClr val="333333"/>
                           </a:solidFill>
@@ -16441,7 +16755,7 @@
                         </a:spcAft>
                       </a:pPr>
                       <a:r>
-                        <a:rPr sz="1200" b="0">
+                        <a:rPr sz="1150" b="0">
                           <a:solidFill>
                             <a:srgbClr val="333333"/>
                           </a:solidFill>
@@ -16498,7 +16812,74 @@
                         </a:spcAft>
                       </a:pPr>
                       <a:r>
-                        <a:rPr sz="1200" b="0">
+                        <a:rPr sz="1150" b="0">
+                          <a:solidFill>
+                            <a:srgbClr val="333333"/>
+                          </a:solidFill>
+                          <a:latin typeface="微软雅黑"/>
+                          <a:ea typeface="微软雅黑"/>
+                        </a:rPr>
+                        <a:t>模型、领域模型 · </a:t>
+                      </a:r>
+                      <a:r>
+                        <a:rPr sz="1150" b="0">
+                          <a:solidFill>
+                            <a:srgbClr val="0070C0"/>
+                          </a:solidFill>
+                          <a:latin typeface="微软雅黑"/>
+                          <a:ea typeface="微软雅黑"/>
+                        </a:rPr>
+                        <a:t>示例：阶段 1–2</a:t>
+                      </a:r>
+                    </a:p>
+                  </a:txBody>
+                  <a:tcPr anchor="ctr">
+                    <a:lnL w="6350" cap="flat" cmpd="sng" algn="ctr">
+                      <a:solidFill>
+                        <a:srgbClr val="D9D9D9"/>
+                      </a:solidFill>
+                      <a:prstDash val="solid"/>
+                    </a:lnL>
+                    <a:lnR w="6350" cap="flat" cmpd="sng" algn="ctr">
+                      <a:solidFill>
+                        <a:srgbClr val="D9D9D9"/>
+                      </a:solidFill>
+                      <a:prstDash val="solid"/>
+                    </a:lnR>
+                    <a:lnT w="6350" cap="flat" cmpd="sng" algn="ctr">
+                      <a:solidFill>
+                        <a:srgbClr val="D9D9D9"/>
+                      </a:solidFill>
+                      <a:prstDash val="solid"/>
+                    </a:lnT>
+                    <a:lnB w="6350" cap="flat" cmpd="sng" algn="ctr">
+                      <a:solidFill>
+                        <a:srgbClr val="D9D9D9"/>
+                      </a:solidFill>
+                      <a:prstDash val="solid"/>
+                    </a:lnB>
+                    <a:solidFill>
+                      <a:srgbClr val="FFFFFF"/>
+                    </a:solidFill>
+                  </a:tcPr>
+                </a:tc>
+                <a:tc>
+                  <a:txBody>
+                    <a:bodyPr wrap="square" lIns="73152" tIns="36576" rIns="73152" bIns="36576" anchor="ctr">
+                      <a:noAutofit/>
+                    </a:bodyPr>
+                    <a:lstStyle/>
+                    <a:p>
+                      <a:pPr algn="l">
+                        <a:lnSpc>
+                          <a:spcPct val="110000"/>
+                        </a:lnSpc>
+                        <a:spcAft>
+                          <a:spcPts val="100"/>
+                        </a:spcAft>
+                      </a:pPr>
+                      <a:r>
+                        <a:rPr sz="1150" b="0">
                           <a:solidFill>
                             <a:srgbClr val="0070C0"/>
                           </a:solidFill>
@@ -16557,7 +16938,7 @@
                         </a:spcAft>
                       </a:pPr>
                       <a:r>
-                        <a:rPr sz="1200" b="1">
+                        <a:rPr sz="1150" b="1">
                           <a:solidFill>
                             <a:srgbClr val="1D1D1A"/>
                           </a:solidFill>
@@ -16614,7 +16995,7 @@
                         </a:spcAft>
                       </a:pPr>
                       <a:r>
-                        <a:rPr sz="1200" b="0">
+                        <a:rPr sz="1150" b="0">
                           <a:solidFill>
                             <a:srgbClr val="333333"/>
                           </a:solidFill>
@@ -16671,7 +17052,7 @@
                         </a:spcAft>
                       </a:pPr>
                       <a:r>
-                        <a:rPr sz="1200" b="0">
+                        <a:rPr sz="1150" b="0">
                           <a:solidFill>
                             <a:srgbClr val="333333"/>
                           </a:solidFill>
@@ -16728,7 +17109,74 @@
                         </a:spcAft>
                       </a:pPr>
                       <a:r>
-                        <a:rPr sz="1200" b="0">
+                        <a:rPr sz="1150" b="0">
+                          <a:solidFill>
+                            <a:srgbClr val="333333"/>
+                          </a:solidFill>
+                          <a:latin typeface="微软雅黑"/>
+                          <a:ea typeface="微软雅黑"/>
+                        </a:rPr>
+                        <a:t>模型、领域模型 · </a:t>
+                      </a:r>
+                      <a:r>
+                        <a:rPr sz="1150" b="0">
+                          <a:solidFill>
+                            <a:srgbClr val="0070C0"/>
+                          </a:solidFill>
+                          <a:latin typeface="微软雅黑"/>
+                          <a:ea typeface="微软雅黑"/>
+                        </a:rPr>
+                        <a:t>示例：阶段 2–3</a:t>
+                      </a:r>
+                    </a:p>
+                  </a:txBody>
+                  <a:tcPr anchor="ctr">
+                    <a:lnL w="6350" cap="flat" cmpd="sng" algn="ctr">
+                      <a:solidFill>
+                        <a:srgbClr val="D9D9D9"/>
+                      </a:solidFill>
+                      <a:prstDash val="solid"/>
+                    </a:lnL>
+                    <a:lnR w="6350" cap="flat" cmpd="sng" algn="ctr">
+                      <a:solidFill>
+                        <a:srgbClr val="D9D9D9"/>
+                      </a:solidFill>
+                      <a:prstDash val="solid"/>
+                    </a:lnR>
+                    <a:lnT w="6350" cap="flat" cmpd="sng" algn="ctr">
+                      <a:solidFill>
+                        <a:srgbClr val="D9D9D9"/>
+                      </a:solidFill>
+                      <a:prstDash val="solid"/>
+                    </a:lnT>
+                    <a:lnB w="6350" cap="flat" cmpd="sng" algn="ctr">
+                      <a:solidFill>
+                        <a:srgbClr val="D9D9D9"/>
+                      </a:solidFill>
+                      <a:prstDash val="solid"/>
+                    </a:lnB>
+                    <a:solidFill>
+                      <a:srgbClr val="FFFFFF"/>
+                    </a:solidFill>
+                  </a:tcPr>
+                </a:tc>
+                <a:tc>
+                  <a:txBody>
+                    <a:bodyPr wrap="square" lIns="73152" tIns="36576" rIns="73152" bIns="36576" anchor="ctr">
+                      <a:noAutofit/>
+                    </a:bodyPr>
+                    <a:lstStyle/>
+                    <a:p>
+                      <a:pPr algn="l">
+                        <a:lnSpc>
+                          <a:spcPct val="110000"/>
+                        </a:lnSpc>
+                        <a:spcAft>
+                          <a:spcPts val="100"/>
+                        </a:spcAft>
+                      </a:pPr>
+                      <a:r>
+                        <a:rPr sz="1150" b="0">
                           <a:solidFill>
                             <a:srgbClr val="0070C0"/>
                           </a:solidFill>
@@ -16787,7 +17235,7 @@
                         </a:spcAft>
                       </a:pPr>
                       <a:r>
-                        <a:rPr sz="1200" b="1">
+                        <a:rPr sz="1150" b="1">
                           <a:solidFill>
                             <a:srgbClr val="1D1D1A"/>
                           </a:solidFill>
@@ -16844,7 +17292,7 @@
                         </a:spcAft>
                       </a:pPr>
                       <a:r>
-                        <a:rPr sz="1200" b="0">
+                        <a:rPr sz="1150" b="0">
                           <a:solidFill>
                             <a:srgbClr val="333333"/>
                           </a:solidFill>
@@ -16901,7 +17349,7 @@
                         </a:spcAft>
                       </a:pPr>
                       <a:r>
-                        <a:rPr sz="1200" b="0">
+                        <a:rPr sz="1150" b="0">
                           <a:solidFill>
                             <a:srgbClr val="333333"/>
                           </a:solidFill>
@@ -16958,7 +17406,74 @@
                         </a:spcAft>
                       </a:pPr>
                       <a:r>
-                        <a:rPr sz="1200" b="0">
+                        <a:rPr sz="1150" b="0">
+                          <a:solidFill>
+                            <a:srgbClr val="333333"/>
+                          </a:solidFill>
+                          <a:latin typeface="微软雅黑"/>
+                          <a:ea typeface="微软雅黑"/>
+                        </a:rPr>
+                        <a:t>APP · </a:t>
+                      </a:r>
+                      <a:r>
+                        <a:rPr sz="1150" b="0">
+                          <a:solidFill>
+                            <a:srgbClr val="0070C0"/>
+                          </a:solidFill>
+                          <a:latin typeface="微软雅黑"/>
+                          <a:ea typeface="微软雅黑"/>
+                        </a:rPr>
+                        <a:t>示例：阶段 3–4</a:t>
+                      </a:r>
+                    </a:p>
+                  </a:txBody>
+                  <a:tcPr anchor="ctr">
+                    <a:lnL w="6350" cap="flat" cmpd="sng" algn="ctr">
+                      <a:solidFill>
+                        <a:srgbClr val="D9D9D9"/>
+                      </a:solidFill>
+                      <a:prstDash val="solid"/>
+                    </a:lnL>
+                    <a:lnR w="6350" cap="flat" cmpd="sng" algn="ctr">
+                      <a:solidFill>
+                        <a:srgbClr val="D9D9D9"/>
+                      </a:solidFill>
+                      <a:prstDash val="solid"/>
+                    </a:lnR>
+                    <a:lnT w="6350" cap="flat" cmpd="sng" algn="ctr">
+                      <a:solidFill>
+                        <a:srgbClr val="D9D9D9"/>
+                      </a:solidFill>
+                      <a:prstDash val="solid"/>
+                    </a:lnT>
+                    <a:lnB w="6350" cap="flat" cmpd="sng" algn="ctr">
+                      <a:solidFill>
+                        <a:srgbClr val="D9D9D9"/>
+                      </a:solidFill>
+                      <a:prstDash val="solid"/>
+                    </a:lnB>
+                    <a:solidFill>
+                      <a:srgbClr val="FFFFFF"/>
+                    </a:solidFill>
+                  </a:tcPr>
+                </a:tc>
+                <a:tc>
+                  <a:txBody>
+                    <a:bodyPr wrap="square" lIns="73152" tIns="36576" rIns="73152" bIns="36576" anchor="ctr">
+                      <a:noAutofit/>
+                    </a:bodyPr>
+                    <a:lstStyle/>
+                    <a:p>
+                      <a:pPr algn="l">
+                        <a:lnSpc>
+                          <a:spcPct val="110000"/>
+                        </a:lnSpc>
+                        <a:spcAft>
+                          <a:spcPts val="100"/>
+                        </a:spcAft>
+                      </a:pPr>
+                      <a:r>
+                        <a:rPr sz="1150" b="0">
                           <a:solidFill>
                             <a:srgbClr val="0070C0"/>
                           </a:solidFill>
@@ -17017,7 +17532,7 @@
                         </a:spcAft>
                       </a:pPr>
                       <a:r>
-                        <a:rPr sz="1200" b="1">
+                        <a:rPr sz="1150" b="1">
                           <a:solidFill>
                             <a:srgbClr val="1D1D1A"/>
                           </a:solidFill>
@@ -17074,7 +17589,7 @@
                         </a:spcAft>
                       </a:pPr>
                       <a:r>
-                        <a:rPr sz="1200" b="0">
+                        <a:rPr sz="1150" b="0">
                           <a:solidFill>
                             <a:srgbClr val="333333"/>
                           </a:solidFill>
@@ -17131,7 +17646,7 @@
                         </a:spcAft>
                       </a:pPr>
                       <a:r>
-                        <a:rPr sz="1200" b="0">
+                        <a:rPr sz="1150" b="0">
                           <a:solidFill>
                             <a:srgbClr val="333333"/>
                           </a:solidFill>
@@ -17188,7 +17703,74 @@
                         </a:spcAft>
                       </a:pPr>
                       <a:r>
-                        <a:rPr sz="1200" b="0">
+                        <a:rPr sz="1150" b="0">
+                          <a:solidFill>
+                            <a:srgbClr val="333333"/>
+                          </a:solidFill>
+                          <a:latin typeface="微软雅黑"/>
+                          <a:ea typeface="微软雅黑"/>
+                        </a:rPr>
+                        <a:t>全部 · </a:t>
+                      </a:r>
+                      <a:r>
+                        <a:rPr sz="1150" b="0">
+                          <a:solidFill>
+                            <a:srgbClr val="0070C0"/>
+                          </a:solidFill>
+                          <a:latin typeface="微软雅黑"/>
+                          <a:ea typeface="微软雅黑"/>
+                        </a:rPr>
+                        <a:t>示例：阶段 4–5</a:t>
+                      </a:r>
+                    </a:p>
+                  </a:txBody>
+                  <a:tcPr anchor="ctr">
+                    <a:lnL w="6350" cap="flat" cmpd="sng" algn="ctr">
+                      <a:solidFill>
+                        <a:srgbClr val="D9D9D9"/>
+                      </a:solidFill>
+                      <a:prstDash val="solid"/>
+                    </a:lnL>
+                    <a:lnR w="6350" cap="flat" cmpd="sng" algn="ctr">
+                      <a:solidFill>
+                        <a:srgbClr val="D9D9D9"/>
+                      </a:solidFill>
+                      <a:prstDash val="solid"/>
+                    </a:lnR>
+                    <a:lnT w="6350" cap="flat" cmpd="sng" algn="ctr">
+                      <a:solidFill>
+                        <a:srgbClr val="D9D9D9"/>
+                      </a:solidFill>
+                      <a:prstDash val="solid"/>
+                    </a:lnT>
+                    <a:lnB w="6350" cap="flat" cmpd="sng" algn="ctr">
+                      <a:solidFill>
+                        <a:srgbClr val="D9D9D9"/>
+                      </a:solidFill>
+                      <a:prstDash val="solid"/>
+                    </a:lnB>
+                    <a:solidFill>
+                      <a:srgbClr val="FFFFFF"/>
+                    </a:solidFill>
+                  </a:tcPr>
+                </a:tc>
+                <a:tc>
+                  <a:txBody>
+                    <a:bodyPr wrap="square" lIns="73152" tIns="36576" rIns="73152" bIns="36576" anchor="ctr">
+                      <a:noAutofit/>
+                    </a:bodyPr>
+                    <a:lstStyle/>
+                    <a:p>
+                      <a:pPr algn="l">
+                        <a:lnSpc>
+                          <a:spcPct val="110000"/>
+                        </a:lnSpc>
+                        <a:spcAft>
+                          <a:spcPts val="100"/>
+                        </a:spcAft>
+                      </a:pPr>
+                      <a:r>
+                        <a:rPr sz="1150" b="0">
                           <a:solidFill>
                             <a:srgbClr val="0070C0"/>
                           </a:solidFill>
@@ -17416,7 +17998,7 @@
                 <a:latin typeface="微软雅黑"/>
                 <a:ea typeface="微软雅黑"/>
               </a:rPr>
-              <a:t>RNP 据此编制本方参与计划；角色按实际任务取舍。</a:t>
+              <a:t>RNP 据此编制本方参与计划；角色按实际任务取舍。这些人也是下一页知识转移的对象。</a:t>
             </a:r>
           </a:p>
         </p:txBody>
@@ -17472,7 +18054,7 @@
                 <a:latin typeface="微软雅黑"/>
                 <a:ea typeface="微软雅黑"/>
               </a:rPr>
-              <a:t>知识转移：两层安排</a:t>
+              <a:t>RNP 能带走什么：知识转移两层安排</a:t>
             </a:r>
           </a:p>
         </p:txBody>
@@ -17485,8 +18067,8 @@
         </p:nvSpPr>
         <p:spPr>
           <a:xfrm>
-            <a:off x="457200" y="1097280"/>
-            <a:ext cx="5454396" cy="3931920"/>
+            <a:off x="457200" y="1051560"/>
+            <a:ext cx="5454396" cy="3749039"/>
           </a:xfrm>
           <a:prstGeom prst="roundRect">
             <a:avLst>
@@ -17531,7 +18113,7 @@
         </p:nvSpPr>
         <p:spPr>
           <a:xfrm>
-            <a:off x="731520" y="1371600"/>
+            <a:off x="731520" y="1325880"/>
             <a:ext cx="3108960" cy="329184"/>
           </a:xfrm>
           <a:prstGeom prst="roundRect">
@@ -17596,7 +18178,7 @@
         </p:nvSpPr>
         <p:spPr>
           <a:xfrm>
-            <a:off x="731520" y="1874519"/>
+            <a:off x="731520" y="1828800"/>
             <a:ext cx="4905756" cy="457200"/>
           </a:xfrm>
           <a:prstGeom prst="rect">
@@ -17639,8 +18221,8 @@
         </p:nvSpPr>
         <p:spPr>
           <a:xfrm>
-            <a:off x="731520" y="2468880"/>
-            <a:ext cx="4905756" cy="2377439"/>
+            <a:off x="731520" y="2423160"/>
+            <a:ext cx="4905756" cy="2194559"/>
           </a:xfrm>
           <a:prstGeom prst="rect">
             <a:avLst/>
@@ -17701,7 +18283,7 @@
                 <a:latin typeface="微软雅黑"/>
                 <a:ea typeface="微软雅黑"/>
               </a:rPr>
-              <a:t>对象：参与项目的巴方人员，名额 </a:t>
+              <a:t>对象：上一页的参与人员，名额 </a:t>
             </a:r>
             <a:r>
               <a:rPr sz="1250" b="0">
@@ -17737,7 +18319,7 @@
                 <a:latin typeface="微软雅黑"/>
                 <a:ea typeface="微软雅黑"/>
               </a:rPr>
-              <a:t>结果：能独立完成数据处理、模型微调、应用部署与运行</a:t>
+              <a:t>结果：数据工程师能独立构建数据集；模型工程师能独立微调与评测；应用开发能独立开发部署；运维工程师能独立运行</a:t>
             </a:r>
           </a:p>
           <a:p>
@@ -17786,8 +18368,8 @@
         </p:nvSpPr>
         <p:spPr>
           <a:xfrm>
-            <a:off x="6277356" y="1097280"/>
-            <a:ext cx="5454396" cy="3931920"/>
+            <a:off x="6277356" y="1051560"/>
+            <a:ext cx="5454396" cy="3749039"/>
           </a:xfrm>
           <a:prstGeom prst="roundRect">
             <a:avLst>
@@ -17832,7 +18414,7 @@
         </p:nvSpPr>
         <p:spPr>
           <a:xfrm>
-            <a:off x="6551676" y="1371600"/>
+            <a:off x="6551676" y="1325880"/>
             <a:ext cx="2377440" cy="329184"/>
           </a:xfrm>
           <a:prstGeom prst="roundRect">
@@ -17897,7 +18479,7 @@
         </p:nvSpPr>
         <p:spPr>
           <a:xfrm>
-            <a:off x="6551676" y="1874519"/>
+            <a:off x="6551676" y="1828800"/>
             <a:ext cx="4905756" cy="457200"/>
           </a:xfrm>
           <a:prstGeom prst="rect">
@@ -17940,8 +18522,8 @@
         </p:nvSpPr>
         <p:spPr>
           <a:xfrm>
-            <a:off x="6551676" y="2468880"/>
-            <a:ext cx="4905756" cy="2377439"/>
+            <a:off x="6551676" y="2423160"/>
+            <a:ext cx="4905756" cy="2194559"/>
           </a:xfrm>
           <a:prstGeom prst="rect">
             <a:avLst/>
@@ -18091,13 +18673,177 @@
       </p:sp>
       <p:sp>
         <p:nvSpPr>
-          <p:cNvPr id="11" name="TextBox 10"/>
+          <p:cNvPr id="11" name="Rounded Rectangle 10"/>
+          <p:cNvSpPr/>
+          <p:nvPr/>
+        </p:nvSpPr>
+        <p:spPr>
+          <a:xfrm>
+            <a:off x="457200" y="4983480"/>
+            <a:ext cx="11274552" cy="548640"/>
+          </a:xfrm>
+          <a:prstGeom prst="roundRect">
+            <a:avLst>
+              <a:gd name="adj" fmla="val 4000"/>
+            </a:avLst>
+          </a:prstGeom>
+          <a:solidFill>
+            <a:srgbClr val="F7F7F7"/>
+          </a:solidFill>
+          <a:ln w="9525">
+            <a:solidFill>
+              <a:srgbClr val="D9D9D9"/>
+            </a:solidFill>
+          </a:ln>
+          <a:effectLst/>
+        </p:spPr>
+        <p:style>
+          <a:lnRef idx="1">
+            <a:schemeClr val="accent1"/>
+          </a:lnRef>
+          <a:fillRef idx="3">
+            <a:schemeClr val="accent1"/>
+          </a:fillRef>
+          <a:effectRef idx="2">
+            <a:schemeClr val="accent1"/>
+          </a:effectRef>
+          <a:fontRef idx="minor">
+            <a:schemeClr val="lt1"/>
+          </a:fontRef>
+        </p:style>
+        <p:txBody>
+          <a:bodyPr rtlCol="0" anchor="ctr"/>
+          <a:lstStyle/>
+          <a:p>
+            <a:pPr algn="ctr"/>
+          </a:p>
+        </p:txBody>
+      </p:sp>
+      <p:sp>
+        <p:nvSpPr>
+          <p:cNvPr id="12" name="TextBox 11"/>
           <p:cNvSpPr txBox="1"/>
           <p:nvPr/>
         </p:nvSpPr>
         <p:spPr>
           <a:xfrm>
-            <a:off x="457200" y="5303520"/>
+            <a:off x="685800" y="5102352"/>
+            <a:ext cx="1645920" cy="310896"/>
+          </a:xfrm>
+          <a:prstGeom prst="rect">
+            <a:avLst/>
+          </a:prstGeom>
+          <a:noFill/>
+        </p:spPr>
+        <p:txBody>
+          <a:bodyPr wrap="square" lIns="0" tIns="0" rIns="0" bIns="0" anchor="ctr">
+            <a:noAutofit/>
+          </a:bodyPr>
+          <a:lstStyle/>
+          <a:p>
+            <a:pPr algn="l">
+              <a:lnSpc>
+                <a:spcPct val="115000"/>
+              </a:lnSpc>
+              <a:spcAft>
+                <a:spcPts val="0"/>
+              </a:spcAft>
+            </a:pPr>
+            <a:r>
+              <a:rPr sz="1250" b="1">
+                <a:solidFill>
+                  <a:srgbClr val="C00000"/>
+                </a:solidFill>
+                <a:latin typeface="微软雅黑"/>
+                <a:ea typeface="微软雅黑"/>
+              </a:rPr>
+              <a:t>整体中的位置</a:t>
+            </a:r>
+          </a:p>
+        </p:txBody>
+      </p:sp>
+      <p:sp>
+        <p:nvSpPr>
+          <p:cNvPr id="13" name="TextBox 12"/>
+          <p:cNvSpPr txBox="1"/>
+          <p:nvPr/>
+        </p:nvSpPr>
+        <p:spPr>
+          <a:xfrm>
+            <a:off x="2331720" y="5093208"/>
+            <a:ext cx="9171432" cy="365759"/>
+          </a:xfrm>
+          <a:prstGeom prst="rect">
+            <a:avLst/>
+          </a:prstGeom>
+          <a:noFill/>
+        </p:spPr>
+        <p:txBody>
+          <a:bodyPr wrap="square" lIns="0" tIns="0" rIns="0" bIns="0" anchor="ctr">
+            <a:noAutofit/>
+          </a:bodyPr>
+          <a:lstStyle/>
+          <a:p>
+            <a:pPr algn="l">
+              <a:lnSpc>
+                <a:spcPct val="115000"/>
+              </a:lnSpc>
+              <a:spcAft>
+                <a:spcPts val="400"/>
+              </a:spcAft>
+            </a:pPr>
+            <a:r>
+              <a:rPr sz="1200" b="0">
+                <a:solidFill>
+                  <a:srgbClr val="333333"/>
+                </a:solidFill>
+                <a:latin typeface="微软雅黑"/>
+                <a:ea typeface="微软雅黑"/>
+              </a:rPr>
+              <a:t>本页是华为能力建设计划（</a:t>
+            </a:r>
+            <a:r>
+              <a:rPr sz="1200" b="0">
+                <a:solidFill>
+                  <a:srgbClr val="0070C0"/>
+                </a:solidFill>
+                <a:latin typeface="微软雅黑"/>
+                <a:ea typeface="微软雅黑"/>
+              </a:rPr>
+              <a:t>示例：2900 人</a:t>
+            </a:r>
+            <a:r>
+              <a:rPr sz="1200" b="0">
+                <a:solidFill>
+                  <a:srgbClr val="333333"/>
+                </a:solidFill>
+                <a:latin typeface="微软雅黑"/>
+                <a:ea typeface="微软雅黑"/>
+              </a:rPr>
+              <a:t>）中讯飞承担的部分，由华为统一汇总为一份 program；</a:t>
+            </a:r>
+            <a:r>
+              <a:rPr sz="1200" b="0">
+                <a:solidFill>
+                  <a:srgbClr val="0070C0"/>
+                </a:solidFill>
+                <a:latin typeface="微软雅黑"/>
+                <a:ea typeface="微软雅黑"/>
+              </a:rPr>
+              <a:t>口径待核实</a:t>
+            </a:r>
+          </a:p>
+        </p:txBody>
+      </p:sp>
+      <p:sp>
+        <p:nvSpPr>
+          <p:cNvPr id="14" name="TextBox 13"/>
+          <p:cNvSpPr txBox="1"/>
+          <p:nvPr/>
+        </p:nvSpPr>
+        <p:spPr>
+          <a:xfrm>
+            <a:off x="457200" y="5715000"/>
             <a:ext cx="11274552" cy="365760"/>
           </a:xfrm>
           <a:prstGeom prst="rect">

</xml_diff>